<commit_message>
Restore full weekly process update copy
</commit_message>
<xml_diff>
--- a/public/one-off-requests/weekly-process-update-aug-sep-2026.pptx
+++ b/public/one-off-requests/weekly-process-update-aug-sep-2026.pptx
@@ -2,11 +2,11 @@
 <file path=ppt/presentation.xml><?xml version="1.0" encoding="utf-8"?>
 <p:presentation xmlns:p="http://schemas.openxmlformats.org/presentationml/2006/main">
   <p:sldMasterIdLst>
-    <p:sldMasterId xmlns:r="http://schemas.openxmlformats.org/officeDocument/2006/relationships" id="2147483648" r:id="R373c0a9648144aa8"/>
+    <p:sldMasterId xmlns:r="http://schemas.openxmlformats.org/officeDocument/2006/relationships" id="2147483648" r:id="R09cdedd4ba564d56"/>
   </p:sldMasterIdLst>
   <p:sldIdLst>
-    <p:sldId xmlns:r="http://schemas.openxmlformats.org/officeDocument/2006/relationships" id="256" r:id="Rd740bc20a9394e62"/>
-    <p:sldId xmlns:r="http://schemas.openxmlformats.org/officeDocument/2006/relationships" id="257" r:id="Rd16e9515921b4834"/>
+    <p:sldId xmlns:r="http://schemas.openxmlformats.org/officeDocument/2006/relationships" id="256" r:id="R6d4a77955e2942ac"/>
+    <p:sldId xmlns:r="http://schemas.openxmlformats.org/officeDocument/2006/relationships" id="257" r:id="R2430c68cf67c40dc"/>
   </p:sldIdLst>
   <p:sldSz cx="12192000" cy="6858000"/>
   <p:notesSz cx="6858000" cy="9144000"/>
@@ -651,7 +651,7 @@
                 <a:ea typeface="Arial"/>
                 <a:cs typeface="Arial"/>
               </a:rPr>
-              <a:t>W</a:t>
+              <a:t>Weekly Process Update</a:t>
             </a:r>
           </a:p>
         </p:txBody>
@@ -710,7 +710,7 @@
                 <a:ea typeface="Arial"/>
                 <a:cs typeface="Arial"/>
               </a:rPr>
-              <a:t>F</a:t>
+              <a:t>Financial Sponsor &amp; Management | As of August 25, 2026</a:t>
             </a:r>
           </a:p>
         </p:txBody>
@@ -893,7 +893,7 @@
                 <a:ea typeface="Arial"/>
                 <a:cs typeface="Arial"/>
               </a:rPr>
-              <a:t>T</a:t>
+              <a:t>TODAY’S AGENDA</a:t>
             </a:r>
           </a:p>
         </p:txBody>
@@ -952,7 +952,7 @@
                 <a:ea typeface="Arial"/>
                 <a:cs typeface="Arial"/>
               </a:rPr>
-              <a:t>0</a:t>
+              <a:t>01</a:t>
             </a:r>
           </a:p>
         </p:txBody>
@@ -1011,7 +1011,7 @@
                 <a:ea typeface="Arial"/>
                 <a:cs typeface="Arial"/>
               </a:rPr>
-              <a:t>P</a:t>
+              <a:t>Process Status &amp; Recent Activity</a:t>
             </a:r>
           </a:p>
         </p:txBody>
@@ -1070,7 +1070,7 @@
                 <a:ea typeface="Arial"/>
                 <a:cs typeface="Arial"/>
               </a:rPr>
-              <a:t>O</a:t>
+              <a:t>Overall progress and key developments</a:t>
             </a:r>
           </a:p>
         </p:txBody>
@@ -1160,7 +1160,7 @@
                 <a:ea typeface="Arial"/>
                 <a:cs typeface="Arial"/>
               </a:rPr>
-              <a:t>0</a:t>
+              <a:t>02</a:t>
             </a:r>
           </a:p>
         </p:txBody>
@@ -1219,7 +1219,7 @@
                 <a:ea typeface="Arial"/>
                 <a:cs typeface="Arial"/>
               </a:rPr>
-              <a:t>B</a:t>
+              <a:t>Buyer Engagement &amp; Feedback</a:t>
             </a:r>
           </a:p>
         </p:txBody>
@@ -1278,7 +1278,7 @@
                 <a:ea typeface="Arial"/>
                 <a:cs typeface="Arial"/>
               </a:rPr>
-              <a:t>O</a:t>
+              <a:t>Outreach, feedback and participation</a:t>
             </a:r>
           </a:p>
         </p:txBody>
@@ -1368,7 +1368,7 @@
                 <a:ea typeface="Arial"/>
                 <a:cs typeface="Arial"/>
               </a:rPr>
-              <a:t>0</a:t>
+              <a:t>03</a:t>
             </a:r>
           </a:p>
         </p:txBody>
@@ -1427,7 +1427,7 @@
                 <a:ea typeface="Arial"/>
                 <a:cs typeface="Arial"/>
               </a:rPr>
-              <a:t>M</a:t>
+              <a:t>Marketing Materials &amp; Data Room</a:t>
             </a:r>
           </a:p>
         </p:txBody>
@@ -1486,7 +1486,7 @@
                 <a:ea typeface="Arial"/>
                 <a:cs typeface="Arial"/>
               </a:rPr>
-              <a:t>C</a:t>
+              <a:t>Content, access and open workstreams</a:t>
             </a:r>
           </a:p>
         </p:txBody>
@@ -1576,7 +1576,7 @@
                 <a:ea typeface="Arial"/>
                 <a:cs typeface="Arial"/>
               </a:rPr>
-              <a:t>0</a:t>
+              <a:t>04</a:t>
             </a:r>
           </a:p>
         </p:txBody>
@@ -1635,7 +1635,7 @@
                 <a:ea typeface="Arial"/>
                 <a:cs typeface="Arial"/>
               </a:rPr>
-              <a:t>D</a:t>
+              <a:t>Diligence &amp; Management Workstreams</a:t>
             </a:r>
           </a:p>
         </p:txBody>
@@ -1694,7 +1694,7 @@
                 <a:ea typeface="Arial"/>
                 <a:cs typeface="Arial"/>
               </a:rPr>
-              <a:t>R</a:t>
+              <a:t>Requests, preparation and dependencies</a:t>
             </a:r>
           </a:p>
         </p:txBody>
@@ -1784,7 +1784,7 @@
                 <a:ea typeface="Arial"/>
                 <a:cs typeface="Arial"/>
               </a:rPr>
-              <a:t>0</a:t>
+              <a:t>05</a:t>
             </a:r>
           </a:p>
         </p:txBody>
@@ -1843,7 +1843,7 @@
                 <a:ea typeface="Arial"/>
                 <a:cs typeface="Arial"/>
               </a:rPr>
-              <a:t>D</a:t>
+              <a:t>Decisions, Owners &amp; Next Steps</a:t>
             </a:r>
           </a:p>
         </p:txBody>
@@ -1902,7 +1902,7 @@
                 <a:ea typeface="Arial"/>
                 <a:cs typeface="Arial"/>
               </a:rPr>
-              <a:t>A</a:t>
+              <a:t>Approvals and priorities for the coming week</a:t>
             </a:r>
           </a:p>
         </p:txBody>
@@ -1992,7 +1992,7 @@
                 <a:ea typeface="Arial"/>
                 <a:cs typeface="Arial"/>
               </a:rPr>
-              <a:t>0</a:t>
+              <a:t>06</a:t>
             </a:r>
           </a:p>
         </p:txBody>
@@ -2051,7 +2051,7 @@
                 <a:ea typeface="Arial"/>
                 <a:cs typeface="Arial"/>
               </a:rPr>
-              <a:t>O</a:t>
+              <a:t>Other Business &amp; Open Discussion</a:t>
             </a:r>
           </a:p>
         </p:txBody>
@@ -2110,7 +2110,7 @@
                 <a:ea typeface="Arial"/>
                 <a:cs typeface="Arial"/>
               </a:rPr>
-              <a:t>A</a:t>
+              <a:t>Additional topics, questions and follow-ups</a:t>
             </a:r>
           </a:p>
         </p:txBody>
@@ -7655,7 +7655,7 @@
                 <a:ea typeface="Arial"/>
                 <a:cs typeface="Arial"/>
               </a:rPr>
-              <a:t>R</a:t>
+              <a:t>RECENTLY COMPLETED</a:t>
             </a:r>
           </a:p>
         </p:txBody>
@@ -7714,7 +7714,7 @@
                 <a:ea typeface="Arial"/>
                 <a:cs typeface="Arial"/>
               </a:rPr>
-              <a:t>U</a:t>
+              <a:t>UPCOMING NEAR-TERM  ·  NEXT 30 DAYS</a:t>
             </a:r>
           </a:p>
         </p:txBody>
@@ -7924,7 +7924,7 @@
                 <a:ea typeface="Arial"/>
                 <a:cs typeface="Arial"/>
               </a:rPr>
-              <a:t>P</a:t>
+              <a:t>Process priorities confirmed</a:t>
             </a:r>
           </a:p>
         </p:txBody>
@@ -8103,7 +8103,7 @@
                 <a:ea typeface="Arial"/>
                 <a:cs typeface="Arial"/>
               </a:rPr>
-              <a:t>B</a:t>
+              <a:t>Buyer universe and outreach aligned</a:t>
             </a:r>
           </a:p>
         </p:txBody>
@@ -8282,7 +8282,7 @@
                 <a:ea typeface="Arial"/>
                 <a:cs typeface="Arial"/>
               </a:rPr>
-              <a:t>T</a:t>
+              <a:t>Teaser / NDA comments closed</a:t>
             </a:r>
           </a:p>
         </p:txBody>
@@ -8463,7 +8463,7 @@
                 <a:ea typeface="Arial"/>
                 <a:cs typeface="Arial"/>
               </a:rPr>
-              <a:t>D</a:t>
+              <a:t>Draft marketing materials circulated</a:t>
             </a:r>
           </a:p>
         </p:txBody>
@@ -8644,7 +8644,7 @@
                 <a:ea typeface="Arial"/>
                 <a:cs typeface="Arial"/>
               </a:rPr>
-              <a:t>S</a:t>
+              <a:t>Sponsor and management review</a:t>
             </a:r>
           </a:p>
         </p:txBody>
@@ -8823,7 +8823,7 @@
                 <a:ea typeface="Arial"/>
                 <a:cs typeface="Arial"/>
               </a:rPr>
-              <a:t>I</a:t>
+              <a:t>Initial buyer outreach begins</a:t>
             </a:r>
           </a:p>
         </p:txBody>
@@ -9004,7 +9004,7 @@
                 <a:ea typeface="Arial"/>
                 <a:cs typeface="Arial"/>
               </a:rPr>
-              <a:t>M</a:t>
+              <a:t>Management presentation preparation</a:t>
             </a:r>
           </a:p>
         </p:txBody>
@@ -9183,7 +9183,7 @@
                 <a:ea typeface="Arial"/>
                 <a:cs typeface="Arial"/>
               </a:rPr>
-              <a:t>I</a:t>
+              <a:t>Initial indications of interest due</a:t>
             </a:r>
           </a:p>
         </p:txBody>
@@ -9271,7 +9271,7 @@
                 <a:ea typeface="Arial"/>
                 <a:cs typeface="Arial"/>
               </a:rPr>
-              <a:t>M</a:t>
+              <a:t>Major Events &amp; Workstreams</a:t>
             </a:r>
           </a:p>
         </p:txBody>
@@ -9330,7 +9330,7 @@
                 <a:ea typeface="Arial"/>
                 <a:cs typeface="Arial"/>
               </a:rPr>
-              <a:t>F</a:t>
+              <a:t>Financial Sponsor &amp; Management | August 2026–January 2027</a:t>
             </a:r>
           </a:p>
         </p:txBody>
@@ -22057,7 +22057,7 @@
                 <a:ea typeface="Arial"/>
                 <a:cs typeface="Arial"/>
               </a:rPr>
-              <a:t>W</a:t>
+              <a:t>WORKSTREAM</a:t>
             </a:r>
           </a:p>
         </p:txBody>
@@ -22116,7 +22116,7 @@
                 <a:ea typeface="Arial"/>
                 <a:cs typeface="Arial"/>
               </a:rPr>
-              <a:t>C</a:t>
+              <a:t>COMMENTARY</a:t>
             </a:r>
           </a:p>
         </p:txBody>
@@ -22268,7 +22268,7 @@
                 <a:ea typeface="Arial"/>
                 <a:cs typeface="Arial"/>
               </a:rPr>
-              <a:t>K</a:t>
+              <a:t>KEY PROCESS PREPARATION</a:t>
             </a:r>
           </a:p>
         </p:txBody>
@@ -22327,7 +22327,7 @@
                 <a:ea typeface="Arial"/>
                 <a:cs typeface="Arial"/>
               </a:rPr>
-              <a:t>A</a:t>
+              <a:t>AUG 25–OCT 15</a:t>
             </a:r>
           </a:p>
         </p:txBody>
@@ -22448,7 +22448,7 @@
                 <a:ea typeface="Arial"/>
                 <a:cs typeface="Arial"/>
               </a:rPr>
-              <a:t>B</a:t>
+              <a:t>Banker Education Materials</a:t>
             </a:r>
           </a:p>
         </p:txBody>
@@ -22538,7 +22538,7 @@
                 <a:ea typeface="Arial"/>
                 <a:cs typeface="Arial"/>
               </a:rPr>
-              <a:t>A</a:t>
+              <a:t>• Add key update</a:t>
             </a:r>
           </a:p>
         </p:txBody>
@@ -22597,7 +22597,7 @@
                 <a:ea typeface="Arial"/>
                 <a:cs typeface="Arial"/>
               </a:rPr>
-              <a:t>A</a:t>
+              <a:t>• Add dependency / next step</a:t>
             </a:r>
           </a:p>
         </p:txBody>
@@ -22749,7 +22749,7 @@
                 <a:ea typeface="Arial"/>
                 <a:cs typeface="Arial"/>
               </a:rPr>
-              <a:t>S</a:t>
+              <a:t>SIP</a:t>
             </a:r>
           </a:p>
         </p:txBody>
@@ -22839,7 +22839,7 @@
                 <a:ea typeface="Arial"/>
                 <a:cs typeface="Arial"/>
               </a:rPr>
-              <a:t>A</a:t>
+              <a:t>• Add key update</a:t>
             </a:r>
           </a:p>
         </p:txBody>
@@ -22898,7 +22898,7 @@
                 <a:ea typeface="Arial"/>
                 <a:cs typeface="Arial"/>
               </a:rPr>
-              <a:t>A</a:t>
+              <a:t>• Add dependency / next step</a:t>
             </a:r>
           </a:p>
         </p:txBody>
@@ -23050,7 +23050,7 @@
                 <a:ea typeface="Arial"/>
                 <a:cs typeface="Arial"/>
               </a:rPr>
-              <a:t>F</a:t>
+              <a:t>Fireside Chat Materials</a:t>
             </a:r>
           </a:p>
         </p:txBody>
@@ -23140,7 +23140,7 @@
                 <a:ea typeface="Arial"/>
                 <a:cs typeface="Arial"/>
               </a:rPr>
-              <a:t>A</a:t>
+              <a:t>• Add key update</a:t>
             </a:r>
           </a:p>
         </p:txBody>
@@ -23199,7 +23199,7 @@
                 <a:ea typeface="Arial"/>
                 <a:cs typeface="Arial"/>
               </a:rPr>
-              <a:t>A</a:t>
+              <a:t>• Add dependency / next step</a:t>
             </a:r>
           </a:p>
         </p:txBody>
@@ -23351,7 +23351,7 @@
                 <a:ea typeface="Arial"/>
                 <a:cs typeface="Arial"/>
               </a:rPr>
-              <a:t>V</a:t>
+              <a:t>VDR Population</a:t>
             </a:r>
           </a:p>
         </p:txBody>
@@ -23441,7 +23441,7 @@
                 <a:ea typeface="Arial"/>
                 <a:cs typeface="Arial"/>
               </a:rPr>
-              <a:t>A</a:t>
+              <a:t>• Add key update</a:t>
             </a:r>
           </a:p>
         </p:txBody>
@@ -23500,7 +23500,7 @@
                 <a:ea typeface="Arial"/>
                 <a:cs typeface="Arial"/>
               </a:rPr>
-              <a:t>A</a:t>
+              <a:t>• Add dependency / next step</a:t>
             </a:r>
           </a:p>
         </p:txBody>
@@ -23652,7 +23652,7 @@
                 <a:ea typeface="Arial"/>
                 <a:cs typeface="Arial"/>
               </a:rPr>
-              <a:t>D</a:t>
+              <a:t>Data Qubes</a:t>
             </a:r>
           </a:p>
         </p:txBody>
@@ -23742,7 +23742,7 @@
                 <a:ea typeface="Arial"/>
                 <a:cs typeface="Arial"/>
               </a:rPr>
-              <a:t>A</a:t>
+              <a:t>• Add key update</a:t>
             </a:r>
           </a:p>
         </p:txBody>
@@ -23801,7 +23801,7 @@
                 <a:ea typeface="Arial"/>
                 <a:cs typeface="Arial"/>
               </a:rPr>
-              <a:t>A</a:t>
+              <a:t>• Add dependency / next step</a:t>
             </a:r>
           </a:p>
         </p:txBody>
@@ -23922,7 +23922,7 @@
                 <a:ea typeface="Arial"/>
                 <a:cs typeface="Arial"/>
               </a:rPr>
-              <a:t>T</a:t>
+              <a:t>THIRD PARTY WORK STREAMS</a:t>
             </a:r>
           </a:p>
         </p:txBody>
@@ -23981,7 +23981,7 @@
                 <a:ea typeface="Arial"/>
                 <a:cs typeface="Arial"/>
               </a:rPr>
-              <a:t>A</a:t>
+              <a:t>ACTIVE FROM AUG 25</a:t>
             </a:r>
           </a:p>
         </p:txBody>
@@ -24102,7 +24102,7 @@
                 <a:ea typeface="Arial"/>
                 <a:cs typeface="Arial"/>
               </a:rPr>
-              <a:t>M</a:t>
+              <a:t>Market Study  —  Aug 25–Oct 6</a:t>
             </a:r>
           </a:p>
         </p:txBody>
@@ -24192,7 +24192,7 @@
                 <a:ea typeface="Arial"/>
                 <a:cs typeface="Arial"/>
               </a:rPr>
-              <a:t>A</a:t>
+              <a:t>• Add key update</a:t>
             </a:r>
           </a:p>
         </p:txBody>
@@ -24251,7 +24251,7 @@
                 <a:ea typeface="Arial"/>
                 <a:cs typeface="Arial"/>
               </a:rPr>
-              <a:t>A</a:t>
+              <a:t>• Add dependency / next step</a:t>
             </a:r>
           </a:p>
         </p:txBody>
@@ -24372,7 +24372,7 @@
                 <a:ea typeface="Arial"/>
                 <a:cs typeface="Arial"/>
               </a:rPr>
-              <a:t>Q</a:t>
+              <a:t>QOE  —  Aug 25–Sep 22</a:t>
             </a:r>
           </a:p>
         </p:txBody>
@@ -24462,7 +24462,7 @@
                 <a:ea typeface="Arial"/>
                 <a:cs typeface="Arial"/>
               </a:rPr>
-              <a:t>A</a:t>
+              <a:t>• Add key update</a:t>
             </a:r>
           </a:p>
         </p:txBody>
@@ -24521,7 +24521,7 @@
                 <a:ea typeface="Arial"/>
                 <a:cs typeface="Arial"/>
               </a:rPr>
-              <a:t>A</a:t>
+              <a:t>• Add dependency / next step</a:t>
             </a:r>
           </a:p>
         </p:txBody>
@@ -24642,7 +24642,7 @@
                 <a:ea typeface="Arial"/>
                 <a:cs typeface="Arial"/>
               </a:rPr>
-              <a:t>K</a:t>
+              <a:t>KEY DATES</a:t>
             </a:r>
           </a:p>
         </p:txBody>
@@ -24701,7 +24701,7 @@
                 <a:ea typeface="Arial"/>
                 <a:cs typeface="Arial"/>
               </a:rPr>
-              <a:t>I</a:t>
+              <a:t>ILLUSTRATIVE DATES  ·  EDITABLE</a:t>
             </a:r>
           </a:p>
         </p:txBody>
@@ -24821,7 +24821,7 @@
                 <a:ea typeface="Arial"/>
                 <a:cs typeface="Arial"/>
               </a:rPr>
-              <a:t>P</a:t>
+              <a:t>Process Launch</a:t>
             </a:r>
           </a:p>
         </p:txBody>
@@ -24880,7 +24880,7 @@
                 <a:ea typeface="Arial"/>
                 <a:cs typeface="Arial"/>
               </a:rPr>
-              <a:t>O</a:t>
+              <a:t>OCT 19</a:t>
             </a:r>
           </a:p>
         </p:txBody>
@@ -25031,7 +25031,7 @@
                 <a:ea typeface="Arial"/>
                 <a:cs typeface="Arial"/>
               </a:rPr>
-              <a:t>P</a:t>
+              <a:t>Phase 1 Bids</a:t>
             </a:r>
           </a:p>
         </p:txBody>
@@ -25090,7 +25090,7 @@
                 <a:ea typeface="Arial"/>
                 <a:cs typeface="Arial"/>
               </a:rPr>
-              <a:t>N</a:t>
+              <a:t>NOV 16</a:t>
             </a:r>
           </a:p>
         </p:txBody>
@@ -25241,7 +25241,7 @@
                 <a:ea typeface="Arial"/>
                 <a:cs typeface="Arial"/>
               </a:rPr>
-              <a:t>C</a:t>
+              <a:t>Check-in Bids</a:t>
             </a:r>
           </a:p>
         </p:txBody>
@@ -25300,7 +25300,7 @@
                 <a:ea typeface="Arial"/>
                 <a:cs typeface="Arial"/>
               </a:rPr>
-              <a:t>D</a:t>
+              <a:t>DEC 7</a:t>
             </a:r>
           </a:p>
         </p:txBody>
@@ -25451,7 +25451,7 @@
                 <a:ea typeface="Arial"/>
                 <a:cs typeface="Arial"/>
               </a:rPr>
-              <a:t>P</a:t>
+              <a:t>Phase 2 Bids</a:t>
             </a:r>
           </a:p>
         </p:txBody>
@@ -25510,7 +25510,7 @@
                 <a:ea typeface="Arial"/>
                 <a:cs typeface="Arial"/>
               </a:rPr>
-              <a:t>J</a:t>
+              <a:t>JAN 11</a:t>
             </a:r>
           </a:p>
         </p:txBody>
@@ -25661,7 +25661,7 @@
                 <a:ea typeface="Arial"/>
                 <a:cs typeface="Arial"/>
               </a:rPr>
-              <a:t>S</a:t>
+              <a:t>Signing</a:t>
             </a:r>
           </a:p>
         </p:txBody>
@@ -25720,7 +25720,7 @@
                 <a:ea typeface="Arial"/>
                 <a:cs typeface="Arial"/>
               </a:rPr>
-              <a:t>J</a:t>
+              <a:t>JAN 29</a:t>
             </a:r>
           </a:p>
         </p:txBody>
@@ -25873,7 +25873,7 @@
                 <a:ea typeface="Arial"/>
                 <a:cs typeface="Arial"/>
               </a:rPr>
-              <a:t>H</a:t>
+              <a:t>Holidays</a:t>
             </a:r>
           </a:p>
         </p:txBody>
@@ -25932,7 +25932,7 @@
                 <a:ea typeface="Arial"/>
                 <a:cs typeface="Arial"/>
               </a:rPr>
-              <a:t>D</a:t>
+              <a:t>DEC 25–JAN 1 + BANK HOLIDAYS</a:t>
             </a:r>
           </a:p>
         </p:txBody>
@@ -37598,6 +37598,7 @@
           <a:lstStyle xmlns:a="http://schemas.openxmlformats.org/drawingml/2006/main"/>
           <a:p xmlns:a="http://schemas.openxmlformats.org/drawingml/2006/main">
             <a:pPr algn="ctr">
+              <a:buNone/>
               <a:defRPr sz="645" b="0">
                 <a:solidFill>
                   <a:srgbClr val="3F3F46"/>
@@ -37656,6 +37657,7 @@
           <a:lstStyle xmlns:a="http://schemas.openxmlformats.org/drawingml/2006/main"/>
           <a:p xmlns:a="http://schemas.openxmlformats.org/drawingml/2006/main">
             <a:pPr algn="ctr">
+              <a:buNone/>
               <a:defRPr sz="645" b="0">
                 <a:solidFill>
                   <a:srgbClr val="3F3F46"/>
@@ -37714,6 +37716,7 @@
           <a:lstStyle xmlns:a="http://schemas.openxmlformats.org/drawingml/2006/main"/>
           <a:p xmlns:a="http://schemas.openxmlformats.org/drawingml/2006/main">
             <a:pPr algn="ctr">
+              <a:buNone/>
               <a:defRPr sz="645" b="0">
                 <a:solidFill>
                   <a:srgbClr val="3F3F46"/>
@@ -37772,6 +37775,7 @@
           <a:lstStyle xmlns:a="http://schemas.openxmlformats.org/drawingml/2006/main"/>
           <a:p xmlns:a="http://schemas.openxmlformats.org/drawingml/2006/main">
             <a:pPr algn="ctr">
+              <a:buNone/>
               <a:defRPr sz="645" b="0">
                 <a:solidFill>
                   <a:srgbClr val="3F3F46"/>
@@ -37830,6 +37834,7 @@
           <a:lstStyle xmlns:a="http://schemas.openxmlformats.org/drawingml/2006/main"/>
           <a:p xmlns:a="http://schemas.openxmlformats.org/drawingml/2006/main">
             <a:pPr algn="ctr">
+              <a:buNone/>
               <a:defRPr sz="645" b="0">
                 <a:solidFill>
                   <a:srgbClr val="3F3F46"/>

</xml_diff>

<commit_message>
Restore full weekly process update copy (#659)
Co-authored-by: Mike Berry <mikeberry6@mikes-mac-mini.tailbfd1cf.ts.net>
</commit_message>
<xml_diff>
--- a/public/one-off-requests/weekly-process-update-aug-sep-2026.pptx
+++ b/public/one-off-requests/weekly-process-update-aug-sep-2026.pptx
@@ -2,11 +2,11 @@
 <file path=ppt/presentation.xml><?xml version="1.0" encoding="utf-8"?>
 <p:presentation xmlns:p="http://schemas.openxmlformats.org/presentationml/2006/main">
   <p:sldMasterIdLst>
-    <p:sldMasterId xmlns:r="http://schemas.openxmlformats.org/officeDocument/2006/relationships" id="2147483648" r:id="R373c0a9648144aa8"/>
+    <p:sldMasterId xmlns:r="http://schemas.openxmlformats.org/officeDocument/2006/relationships" id="2147483648" r:id="R09cdedd4ba564d56"/>
   </p:sldMasterIdLst>
   <p:sldIdLst>
-    <p:sldId xmlns:r="http://schemas.openxmlformats.org/officeDocument/2006/relationships" id="256" r:id="Rd740bc20a9394e62"/>
-    <p:sldId xmlns:r="http://schemas.openxmlformats.org/officeDocument/2006/relationships" id="257" r:id="Rd16e9515921b4834"/>
+    <p:sldId xmlns:r="http://schemas.openxmlformats.org/officeDocument/2006/relationships" id="256" r:id="R6d4a77955e2942ac"/>
+    <p:sldId xmlns:r="http://schemas.openxmlformats.org/officeDocument/2006/relationships" id="257" r:id="R2430c68cf67c40dc"/>
   </p:sldIdLst>
   <p:sldSz cx="12192000" cy="6858000"/>
   <p:notesSz cx="6858000" cy="9144000"/>
@@ -651,7 +651,7 @@
                 <a:ea typeface="Arial"/>
                 <a:cs typeface="Arial"/>
               </a:rPr>
-              <a:t>W</a:t>
+              <a:t>Weekly Process Update</a:t>
             </a:r>
           </a:p>
         </p:txBody>
@@ -710,7 +710,7 @@
                 <a:ea typeface="Arial"/>
                 <a:cs typeface="Arial"/>
               </a:rPr>
-              <a:t>F</a:t>
+              <a:t>Financial Sponsor &amp; Management | As of August 25, 2026</a:t>
             </a:r>
           </a:p>
         </p:txBody>
@@ -893,7 +893,7 @@
                 <a:ea typeface="Arial"/>
                 <a:cs typeface="Arial"/>
               </a:rPr>
-              <a:t>T</a:t>
+              <a:t>TODAY’S AGENDA</a:t>
             </a:r>
           </a:p>
         </p:txBody>
@@ -952,7 +952,7 @@
                 <a:ea typeface="Arial"/>
                 <a:cs typeface="Arial"/>
               </a:rPr>
-              <a:t>0</a:t>
+              <a:t>01</a:t>
             </a:r>
           </a:p>
         </p:txBody>
@@ -1011,7 +1011,7 @@
                 <a:ea typeface="Arial"/>
                 <a:cs typeface="Arial"/>
               </a:rPr>
-              <a:t>P</a:t>
+              <a:t>Process Status &amp; Recent Activity</a:t>
             </a:r>
           </a:p>
         </p:txBody>
@@ -1070,7 +1070,7 @@
                 <a:ea typeface="Arial"/>
                 <a:cs typeface="Arial"/>
               </a:rPr>
-              <a:t>O</a:t>
+              <a:t>Overall progress and key developments</a:t>
             </a:r>
           </a:p>
         </p:txBody>
@@ -1160,7 +1160,7 @@
                 <a:ea typeface="Arial"/>
                 <a:cs typeface="Arial"/>
               </a:rPr>
-              <a:t>0</a:t>
+              <a:t>02</a:t>
             </a:r>
           </a:p>
         </p:txBody>
@@ -1219,7 +1219,7 @@
                 <a:ea typeface="Arial"/>
                 <a:cs typeface="Arial"/>
               </a:rPr>
-              <a:t>B</a:t>
+              <a:t>Buyer Engagement &amp; Feedback</a:t>
             </a:r>
           </a:p>
         </p:txBody>
@@ -1278,7 +1278,7 @@
                 <a:ea typeface="Arial"/>
                 <a:cs typeface="Arial"/>
               </a:rPr>
-              <a:t>O</a:t>
+              <a:t>Outreach, feedback and participation</a:t>
             </a:r>
           </a:p>
         </p:txBody>
@@ -1368,7 +1368,7 @@
                 <a:ea typeface="Arial"/>
                 <a:cs typeface="Arial"/>
               </a:rPr>
-              <a:t>0</a:t>
+              <a:t>03</a:t>
             </a:r>
           </a:p>
         </p:txBody>
@@ -1427,7 +1427,7 @@
                 <a:ea typeface="Arial"/>
                 <a:cs typeface="Arial"/>
               </a:rPr>
-              <a:t>M</a:t>
+              <a:t>Marketing Materials &amp; Data Room</a:t>
             </a:r>
           </a:p>
         </p:txBody>
@@ -1486,7 +1486,7 @@
                 <a:ea typeface="Arial"/>
                 <a:cs typeface="Arial"/>
               </a:rPr>
-              <a:t>C</a:t>
+              <a:t>Content, access and open workstreams</a:t>
             </a:r>
           </a:p>
         </p:txBody>
@@ -1576,7 +1576,7 @@
                 <a:ea typeface="Arial"/>
                 <a:cs typeface="Arial"/>
               </a:rPr>
-              <a:t>0</a:t>
+              <a:t>04</a:t>
             </a:r>
           </a:p>
         </p:txBody>
@@ -1635,7 +1635,7 @@
                 <a:ea typeface="Arial"/>
                 <a:cs typeface="Arial"/>
               </a:rPr>
-              <a:t>D</a:t>
+              <a:t>Diligence &amp; Management Workstreams</a:t>
             </a:r>
           </a:p>
         </p:txBody>
@@ -1694,7 +1694,7 @@
                 <a:ea typeface="Arial"/>
                 <a:cs typeface="Arial"/>
               </a:rPr>
-              <a:t>R</a:t>
+              <a:t>Requests, preparation and dependencies</a:t>
             </a:r>
           </a:p>
         </p:txBody>
@@ -1784,7 +1784,7 @@
                 <a:ea typeface="Arial"/>
                 <a:cs typeface="Arial"/>
               </a:rPr>
-              <a:t>0</a:t>
+              <a:t>05</a:t>
             </a:r>
           </a:p>
         </p:txBody>
@@ -1843,7 +1843,7 @@
                 <a:ea typeface="Arial"/>
                 <a:cs typeface="Arial"/>
               </a:rPr>
-              <a:t>D</a:t>
+              <a:t>Decisions, Owners &amp; Next Steps</a:t>
             </a:r>
           </a:p>
         </p:txBody>
@@ -1902,7 +1902,7 @@
                 <a:ea typeface="Arial"/>
                 <a:cs typeface="Arial"/>
               </a:rPr>
-              <a:t>A</a:t>
+              <a:t>Approvals and priorities for the coming week</a:t>
             </a:r>
           </a:p>
         </p:txBody>
@@ -1992,7 +1992,7 @@
                 <a:ea typeface="Arial"/>
                 <a:cs typeface="Arial"/>
               </a:rPr>
-              <a:t>0</a:t>
+              <a:t>06</a:t>
             </a:r>
           </a:p>
         </p:txBody>
@@ -2051,7 +2051,7 @@
                 <a:ea typeface="Arial"/>
                 <a:cs typeface="Arial"/>
               </a:rPr>
-              <a:t>O</a:t>
+              <a:t>Other Business &amp; Open Discussion</a:t>
             </a:r>
           </a:p>
         </p:txBody>
@@ -2110,7 +2110,7 @@
                 <a:ea typeface="Arial"/>
                 <a:cs typeface="Arial"/>
               </a:rPr>
-              <a:t>A</a:t>
+              <a:t>Additional topics, questions and follow-ups</a:t>
             </a:r>
           </a:p>
         </p:txBody>
@@ -7655,7 +7655,7 @@
                 <a:ea typeface="Arial"/>
                 <a:cs typeface="Arial"/>
               </a:rPr>
-              <a:t>R</a:t>
+              <a:t>RECENTLY COMPLETED</a:t>
             </a:r>
           </a:p>
         </p:txBody>
@@ -7714,7 +7714,7 @@
                 <a:ea typeface="Arial"/>
                 <a:cs typeface="Arial"/>
               </a:rPr>
-              <a:t>U</a:t>
+              <a:t>UPCOMING NEAR-TERM  ·  NEXT 30 DAYS</a:t>
             </a:r>
           </a:p>
         </p:txBody>
@@ -7924,7 +7924,7 @@
                 <a:ea typeface="Arial"/>
                 <a:cs typeface="Arial"/>
               </a:rPr>
-              <a:t>P</a:t>
+              <a:t>Process priorities confirmed</a:t>
             </a:r>
           </a:p>
         </p:txBody>
@@ -8103,7 +8103,7 @@
                 <a:ea typeface="Arial"/>
                 <a:cs typeface="Arial"/>
               </a:rPr>
-              <a:t>B</a:t>
+              <a:t>Buyer universe and outreach aligned</a:t>
             </a:r>
           </a:p>
         </p:txBody>
@@ -8282,7 +8282,7 @@
                 <a:ea typeface="Arial"/>
                 <a:cs typeface="Arial"/>
               </a:rPr>
-              <a:t>T</a:t>
+              <a:t>Teaser / NDA comments closed</a:t>
             </a:r>
           </a:p>
         </p:txBody>
@@ -8463,7 +8463,7 @@
                 <a:ea typeface="Arial"/>
                 <a:cs typeface="Arial"/>
               </a:rPr>
-              <a:t>D</a:t>
+              <a:t>Draft marketing materials circulated</a:t>
             </a:r>
           </a:p>
         </p:txBody>
@@ -8644,7 +8644,7 @@
                 <a:ea typeface="Arial"/>
                 <a:cs typeface="Arial"/>
               </a:rPr>
-              <a:t>S</a:t>
+              <a:t>Sponsor and management review</a:t>
             </a:r>
           </a:p>
         </p:txBody>
@@ -8823,7 +8823,7 @@
                 <a:ea typeface="Arial"/>
                 <a:cs typeface="Arial"/>
               </a:rPr>
-              <a:t>I</a:t>
+              <a:t>Initial buyer outreach begins</a:t>
             </a:r>
           </a:p>
         </p:txBody>
@@ -9004,7 +9004,7 @@
                 <a:ea typeface="Arial"/>
                 <a:cs typeface="Arial"/>
               </a:rPr>
-              <a:t>M</a:t>
+              <a:t>Management presentation preparation</a:t>
             </a:r>
           </a:p>
         </p:txBody>
@@ -9183,7 +9183,7 @@
                 <a:ea typeface="Arial"/>
                 <a:cs typeface="Arial"/>
               </a:rPr>
-              <a:t>I</a:t>
+              <a:t>Initial indications of interest due</a:t>
             </a:r>
           </a:p>
         </p:txBody>
@@ -9271,7 +9271,7 @@
                 <a:ea typeface="Arial"/>
                 <a:cs typeface="Arial"/>
               </a:rPr>
-              <a:t>M</a:t>
+              <a:t>Major Events &amp; Workstreams</a:t>
             </a:r>
           </a:p>
         </p:txBody>
@@ -9330,7 +9330,7 @@
                 <a:ea typeface="Arial"/>
                 <a:cs typeface="Arial"/>
               </a:rPr>
-              <a:t>F</a:t>
+              <a:t>Financial Sponsor &amp; Management | August 2026–January 2027</a:t>
             </a:r>
           </a:p>
         </p:txBody>
@@ -22057,7 +22057,7 @@
                 <a:ea typeface="Arial"/>
                 <a:cs typeface="Arial"/>
               </a:rPr>
-              <a:t>W</a:t>
+              <a:t>WORKSTREAM</a:t>
             </a:r>
           </a:p>
         </p:txBody>
@@ -22116,7 +22116,7 @@
                 <a:ea typeface="Arial"/>
                 <a:cs typeface="Arial"/>
               </a:rPr>
-              <a:t>C</a:t>
+              <a:t>COMMENTARY</a:t>
             </a:r>
           </a:p>
         </p:txBody>
@@ -22268,7 +22268,7 @@
                 <a:ea typeface="Arial"/>
                 <a:cs typeface="Arial"/>
               </a:rPr>
-              <a:t>K</a:t>
+              <a:t>KEY PROCESS PREPARATION</a:t>
             </a:r>
           </a:p>
         </p:txBody>
@@ -22327,7 +22327,7 @@
                 <a:ea typeface="Arial"/>
                 <a:cs typeface="Arial"/>
               </a:rPr>
-              <a:t>A</a:t>
+              <a:t>AUG 25–OCT 15</a:t>
             </a:r>
           </a:p>
         </p:txBody>
@@ -22448,7 +22448,7 @@
                 <a:ea typeface="Arial"/>
                 <a:cs typeface="Arial"/>
               </a:rPr>
-              <a:t>B</a:t>
+              <a:t>Banker Education Materials</a:t>
             </a:r>
           </a:p>
         </p:txBody>
@@ -22538,7 +22538,7 @@
                 <a:ea typeface="Arial"/>
                 <a:cs typeface="Arial"/>
               </a:rPr>
-              <a:t>A</a:t>
+              <a:t>• Add key update</a:t>
             </a:r>
           </a:p>
         </p:txBody>
@@ -22597,7 +22597,7 @@
                 <a:ea typeface="Arial"/>
                 <a:cs typeface="Arial"/>
               </a:rPr>
-              <a:t>A</a:t>
+              <a:t>• Add dependency / next step</a:t>
             </a:r>
           </a:p>
         </p:txBody>
@@ -22749,7 +22749,7 @@
                 <a:ea typeface="Arial"/>
                 <a:cs typeface="Arial"/>
               </a:rPr>
-              <a:t>S</a:t>
+              <a:t>SIP</a:t>
             </a:r>
           </a:p>
         </p:txBody>
@@ -22839,7 +22839,7 @@
                 <a:ea typeface="Arial"/>
                 <a:cs typeface="Arial"/>
               </a:rPr>
-              <a:t>A</a:t>
+              <a:t>• Add key update</a:t>
             </a:r>
           </a:p>
         </p:txBody>
@@ -22898,7 +22898,7 @@
                 <a:ea typeface="Arial"/>
                 <a:cs typeface="Arial"/>
               </a:rPr>
-              <a:t>A</a:t>
+              <a:t>• Add dependency / next step</a:t>
             </a:r>
           </a:p>
         </p:txBody>
@@ -23050,7 +23050,7 @@
                 <a:ea typeface="Arial"/>
                 <a:cs typeface="Arial"/>
               </a:rPr>
-              <a:t>F</a:t>
+              <a:t>Fireside Chat Materials</a:t>
             </a:r>
           </a:p>
         </p:txBody>
@@ -23140,7 +23140,7 @@
                 <a:ea typeface="Arial"/>
                 <a:cs typeface="Arial"/>
               </a:rPr>
-              <a:t>A</a:t>
+              <a:t>• Add key update</a:t>
             </a:r>
           </a:p>
         </p:txBody>
@@ -23199,7 +23199,7 @@
                 <a:ea typeface="Arial"/>
                 <a:cs typeface="Arial"/>
               </a:rPr>
-              <a:t>A</a:t>
+              <a:t>• Add dependency / next step</a:t>
             </a:r>
           </a:p>
         </p:txBody>
@@ -23351,7 +23351,7 @@
                 <a:ea typeface="Arial"/>
                 <a:cs typeface="Arial"/>
               </a:rPr>
-              <a:t>V</a:t>
+              <a:t>VDR Population</a:t>
             </a:r>
           </a:p>
         </p:txBody>
@@ -23441,7 +23441,7 @@
                 <a:ea typeface="Arial"/>
                 <a:cs typeface="Arial"/>
               </a:rPr>
-              <a:t>A</a:t>
+              <a:t>• Add key update</a:t>
             </a:r>
           </a:p>
         </p:txBody>
@@ -23500,7 +23500,7 @@
                 <a:ea typeface="Arial"/>
                 <a:cs typeface="Arial"/>
               </a:rPr>
-              <a:t>A</a:t>
+              <a:t>• Add dependency / next step</a:t>
             </a:r>
           </a:p>
         </p:txBody>
@@ -23652,7 +23652,7 @@
                 <a:ea typeface="Arial"/>
                 <a:cs typeface="Arial"/>
               </a:rPr>
-              <a:t>D</a:t>
+              <a:t>Data Qubes</a:t>
             </a:r>
           </a:p>
         </p:txBody>
@@ -23742,7 +23742,7 @@
                 <a:ea typeface="Arial"/>
                 <a:cs typeface="Arial"/>
               </a:rPr>
-              <a:t>A</a:t>
+              <a:t>• Add key update</a:t>
             </a:r>
           </a:p>
         </p:txBody>
@@ -23801,7 +23801,7 @@
                 <a:ea typeface="Arial"/>
                 <a:cs typeface="Arial"/>
               </a:rPr>
-              <a:t>A</a:t>
+              <a:t>• Add dependency / next step</a:t>
             </a:r>
           </a:p>
         </p:txBody>
@@ -23922,7 +23922,7 @@
                 <a:ea typeface="Arial"/>
                 <a:cs typeface="Arial"/>
               </a:rPr>
-              <a:t>T</a:t>
+              <a:t>THIRD PARTY WORK STREAMS</a:t>
             </a:r>
           </a:p>
         </p:txBody>
@@ -23981,7 +23981,7 @@
                 <a:ea typeface="Arial"/>
                 <a:cs typeface="Arial"/>
               </a:rPr>
-              <a:t>A</a:t>
+              <a:t>ACTIVE FROM AUG 25</a:t>
             </a:r>
           </a:p>
         </p:txBody>
@@ -24102,7 +24102,7 @@
                 <a:ea typeface="Arial"/>
                 <a:cs typeface="Arial"/>
               </a:rPr>
-              <a:t>M</a:t>
+              <a:t>Market Study  —  Aug 25–Oct 6</a:t>
             </a:r>
           </a:p>
         </p:txBody>
@@ -24192,7 +24192,7 @@
                 <a:ea typeface="Arial"/>
                 <a:cs typeface="Arial"/>
               </a:rPr>
-              <a:t>A</a:t>
+              <a:t>• Add key update</a:t>
             </a:r>
           </a:p>
         </p:txBody>
@@ -24251,7 +24251,7 @@
                 <a:ea typeface="Arial"/>
                 <a:cs typeface="Arial"/>
               </a:rPr>
-              <a:t>A</a:t>
+              <a:t>• Add dependency / next step</a:t>
             </a:r>
           </a:p>
         </p:txBody>
@@ -24372,7 +24372,7 @@
                 <a:ea typeface="Arial"/>
                 <a:cs typeface="Arial"/>
               </a:rPr>
-              <a:t>Q</a:t>
+              <a:t>QOE  —  Aug 25–Sep 22</a:t>
             </a:r>
           </a:p>
         </p:txBody>
@@ -24462,7 +24462,7 @@
                 <a:ea typeface="Arial"/>
                 <a:cs typeface="Arial"/>
               </a:rPr>
-              <a:t>A</a:t>
+              <a:t>• Add key update</a:t>
             </a:r>
           </a:p>
         </p:txBody>
@@ -24521,7 +24521,7 @@
                 <a:ea typeface="Arial"/>
                 <a:cs typeface="Arial"/>
               </a:rPr>
-              <a:t>A</a:t>
+              <a:t>• Add dependency / next step</a:t>
             </a:r>
           </a:p>
         </p:txBody>
@@ -24642,7 +24642,7 @@
                 <a:ea typeface="Arial"/>
                 <a:cs typeface="Arial"/>
               </a:rPr>
-              <a:t>K</a:t>
+              <a:t>KEY DATES</a:t>
             </a:r>
           </a:p>
         </p:txBody>
@@ -24701,7 +24701,7 @@
                 <a:ea typeface="Arial"/>
                 <a:cs typeface="Arial"/>
               </a:rPr>
-              <a:t>I</a:t>
+              <a:t>ILLUSTRATIVE DATES  ·  EDITABLE</a:t>
             </a:r>
           </a:p>
         </p:txBody>
@@ -24821,7 +24821,7 @@
                 <a:ea typeface="Arial"/>
                 <a:cs typeface="Arial"/>
               </a:rPr>
-              <a:t>P</a:t>
+              <a:t>Process Launch</a:t>
             </a:r>
           </a:p>
         </p:txBody>
@@ -24880,7 +24880,7 @@
                 <a:ea typeface="Arial"/>
                 <a:cs typeface="Arial"/>
               </a:rPr>
-              <a:t>O</a:t>
+              <a:t>OCT 19</a:t>
             </a:r>
           </a:p>
         </p:txBody>
@@ -25031,7 +25031,7 @@
                 <a:ea typeface="Arial"/>
                 <a:cs typeface="Arial"/>
               </a:rPr>
-              <a:t>P</a:t>
+              <a:t>Phase 1 Bids</a:t>
             </a:r>
           </a:p>
         </p:txBody>
@@ -25090,7 +25090,7 @@
                 <a:ea typeface="Arial"/>
                 <a:cs typeface="Arial"/>
               </a:rPr>
-              <a:t>N</a:t>
+              <a:t>NOV 16</a:t>
             </a:r>
           </a:p>
         </p:txBody>
@@ -25241,7 +25241,7 @@
                 <a:ea typeface="Arial"/>
                 <a:cs typeface="Arial"/>
               </a:rPr>
-              <a:t>C</a:t>
+              <a:t>Check-in Bids</a:t>
             </a:r>
           </a:p>
         </p:txBody>
@@ -25300,7 +25300,7 @@
                 <a:ea typeface="Arial"/>
                 <a:cs typeface="Arial"/>
               </a:rPr>
-              <a:t>D</a:t>
+              <a:t>DEC 7</a:t>
             </a:r>
           </a:p>
         </p:txBody>
@@ -25451,7 +25451,7 @@
                 <a:ea typeface="Arial"/>
                 <a:cs typeface="Arial"/>
               </a:rPr>
-              <a:t>P</a:t>
+              <a:t>Phase 2 Bids</a:t>
             </a:r>
           </a:p>
         </p:txBody>
@@ -25510,7 +25510,7 @@
                 <a:ea typeface="Arial"/>
                 <a:cs typeface="Arial"/>
               </a:rPr>
-              <a:t>J</a:t>
+              <a:t>JAN 11</a:t>
             </a:r>
           </a:p>
         </p:txBody>
@@ -25661,7 +25661,7 @@
                 <a:ea typeface="Arial"/>
                 <a:cs typeface="Arial"/>
               </a:rPr>
-              <a:t>S</a:t>
+              <a:t>Signing</a:t>
             </a:r>
           </a:p>
         </p:txBody>
@@ -25720,7 +25720,7 @@
                 <a:ea typeface="Arial"/>
                 <a:cs typeface="Arial"/>
               </a:rPr>
-              <a:t>J</a:t>
+              <a:t>JAN 29</a:t>
             </a:r>
           </a:p>
         </p:txBody>
@@ -25873,7 +25873,7 @@
                 <a:ea typeface="Arial"/>
                 <a:cs typeface="Arial"/>
               </a:rPr>
-              <a:t>H</a:t>
+              <a:t>Holidays</a:t>
             </a:r>
           </a:p>
         </p:txBody>
@@ -25932,7 +25932,7 @@
                 <a:ea typeface="Arial"/>
                 <a:cs typeface="Arial"/>
               </a:rPr>
-              <a:t>D</a:t>
+              <a:t>DEC 25–JAN 1 + BANK HOLIDAYS</a:t>
             </a:r>
           </a:p>
         </p:txBody>
@@ -37598,6 +37598,7 @@
           <a:lstStyle xmlns:a="http://schemas.openxmlformats.org/drawingml/2006/main"/>
           <a:p xmlns:a="http://schemas.openxmlformats.org/drawingml/2006/main">
             <a:pPr algn="ctr">
+              <a:buNone/>
               <a:defRPr sz="645" b="0">
                 <a:solidFill>
                   <a:srgbClr val="3F3F46"/>
@@ -37656,6 +37657,7 @@
           <a:lstStyle xmlns:a="http://schemas.openxmlformats.org/drawingml/2006/main"/>
           <a:p xmlns:a="http://schemas.openxmlformats.org/drawingml/2006/main">
             <a:pPr algn="ctr">
+              <a:buNone/>
               <a:defRPr sz="645" b="0">
                 <a:solidFill>
                   <a:srgbClr val="3F3F46"/>
@@ -37714,6 +37716,7 @@
           <a:lstStyle xmlns:a="http://schemas.openxmlformats.org/drawingml/2006/main"/>
           <a:p xmlns:a="http://schemas.openxmlformats.org/drawingml/2006/main">
             <a:pPr algn="ctr">
+              <a:buNone/>
               <a:defRPr sz="645" b="0">
                 <a:solidFill>
                   <a:srgbClr val="3F3F46"/>
@@ -37772,6 +37775,7 @@
           <a:lstStyle xmlns:a="http://schemas.openxmlformats.org/drawingml/2006/main"/>
           <a:p xmlns:a="http://schemas.openxmlformats.org/drawingml/2006/main">
             <a:pPr algn="ctr">
+              <a:buNone/>
               <a:defRPr sz="645" b="0">
                 <a:solidFill>
                   <a:srgbClr val="3F3F46"/>
@@ -37830,6 +37834,7 @@
           <a:lstStyle xmlns:a="http://schemas.openxmlformats.org/drawingml/2006/main"/>
           <a:p xmlns:a="http://schemas.openxmlformats.org/drawingml/2006/main">
             <a:pPr algn="ctr">
+              <a:buNone/>
               <a:defRPr sz="645" b="0">
                 <a:solidFill>
                   <a:srgbClr val="3F3F46"/>

</xml_diff>